<commit_message>
docs: update project showcase presentation
</commit_message>
<xml_diff>
--- a/docs/presentations/2026-08-24-project-showcase-extended-v3.pptx
+++ b/docs/presentations/2026-08-24-project-showcase-extended-v3.pptx
@@ -347,29 +347,64 @@
           <a:lstStyle/>
           <a:p>
             <a:r>
-              <a:t>今天不是報告完成百分比，而是用一個真實多人 AI 產品，說明我如何把產品問題轉成 AWS 架構、風險控制與可驗證維運。</a:t>
-            </a:r>
-          </a:p>
-          <a:p>
-            <a:endParaRPr/>
-          </a:p>
-          <a:p>
-            <a:r>
+              <a:rPr dirty="0" err="1"/>
+              <a:t>今天不是報告完成百分比，而是用一個真實多人</a:t>
+            </a:r>
+            <a:r>
+              <a:rPr dirty="0"/>
+              <a:t> AI </a:t>
+            </a:r>
+            <a:r>
+              <a:rPr dirty="0" err="1"/>
+              <a:t>產品，說明我如何把產品問題轉成</a:t>
+            </a:r>
+            <a:r>
+              <a:rPr dirty="0"/>
+              <a:t> AWS </a:t>
+            </a:r>
+            <a:r>
+              <a:rPr dirty="0" err="1"/>
+              <a:t>架構、風險控制與可驗證維運</a:t>
+            </a:r>
+            <a:r>
+              <a:rPr dirty="0"/>
+              <a:t>。</a:t>
+            </a:r>
+          </a:p>
+          <a:p>
+            <a:endParaRPr dirty="0"/>
+          </a:p>
+          <a:p>
+            <a:r>
+              <a:rPr dirty="0"/>
               <a:t>[Sources]</a:t>
             </a:r>
           </a:p>
           <a:p>
             <a:r>
-              <a:t>- docs/handoffs/CURRENT.md</a:t>
-            </a:r>
-          </a:p>
-          <a:p>
-            <a:r>
-              <a:t>- docs/evidence/2026-08-20-tier0-four-player-trial/validation.md</a:t>
-            </a:r>
-          </a:p>
-          <a:p>
-            <a:r>
+              <a:rPr dirty="0"/>
+              <a:t>- docs/handoffs/</a:t>
+            </a:r>
+            <a:r>
+              <a:rPr dirty="0" err="1"/>
+              <a:t>CURRENT.md</a:t>
+            </a:r>
+            <a:endParaRPr dirty="0"/>
+          </a:p>
+          <a:p>
+            <a:r>
+              <a:rPr dirty="0"/>
+              <a:t>- docs/evidence/2026-08-20-tier0-four-player-trial/</a:t>
+            </a:r>
+            <a:r>
+              <a:rPr dirty="0" err="1"/>
+              <a:t>validation.md</a:t>
+            </a:r>
+            <a:endParaRPr dirty="0"/>
+          </a:p>
+          <a:p>
+            <a:r>
+              <a:rPr dirty="0"/>
               <a:t>[/Sources]</a:t>
             </a:r>
           </a:p>
@@ -447,34 +482,118 @@
           <a:lstStyle/>
           <a:p>
             <a:r>
-              <a:t>FastAPI 只是入口。Room Service 管理房間生命週期，Domain Rules 決定骰子、進度、危機與結局；RDS 和 Bedrock 都隔離在 adapters。這讓一致性規則、資料持久化與 AI 敘事可以獨立測試，也讓 production wiring 能 fail closed。</a:t>
-            </a:r>
-          </a:p>
-          <a:p>
-            <a:endParaRPr/>
-          </a:p>
-          <a:p>
-            <a:r>
+              <a:rPr dirty="0" err="1"/>
+              <a:t>FastAPI</a:t>
+            </a:r>
+            <a:r>
+              <a:rPr dirty="0"/>
+              <a:t> </a:t>
+            </a:r>
+            <a:r>
+              <a:rPr dirty="0" err="1"/>
+              <a:t>只是入口。Room</a:t>
+            </a:r>
+            <a:r>
+              <a:rPr dirty="0"/>
+              <a:t> Service </a:t>
+            </a:r>
+            <a:r>
+              <a:rPr dirty="0" err="1"/>
+              <a:t>管理房間生命週期，Domain</a:t>
+            </a:r>
+            <a:r>
+              <a:rPr dirty="0"/>
+              <a:t> Rules </a:t>
+            </a:r>
+            <a:r>
+              <a:rPr dirty="0" err="1"/>
+              <a:t>決定骰子、進度、危機與結局；RDS</a:t>
+            </a:r>
+            <a:r>
+              <a:rPr dirty="0"/>
+              <a:t> </a:t>
+            </a:r>
+            <a:r>
+              <a:rPr dirty="0" err="1"/>
+              <a:t>和</a:t>
+            </a:r>
+            <a:r>
+              <a:rPr dirty="0"/>
+              <a:t> Bedrock </a:t>
+            </a:r>
+            <a:r>
+              <a:rPr dirty="0" err="1"/>
+              <a:t>都隔離在</a:t>
+            </a:r>
+            <a:r>
+              <a:rPr dirty="0"/>
+              <a:t> </a:t>
+            </a:r>
+            <a:r>
+              <a:rPr dirty="0" err="1"/>
+              <a:t>adapters。這讓一致性規則、資料持久化與</a:t>
+            </a:r>
+            <a:r>
+              <a:rPr dirty="0"/>
+              <a:t> AI </a:t>
+            </a:r>
+            <a:r>
+              <a:rPr dirty="0" err="1"/>
+              <a:t>敘事可以獨立測試，也讓</a:t>
+            </a:r>
+            <a:r>
+              <a:rPr dirty="0"/>
+              <a:t> production wiring </a:t>
+            </a:r>
+            <a:r>
+              <a:rPr dirty="0" err="1"/>
+              <a:t>能</a:t>
+            </a:r>
+            <a:r>
+              <a:rPr dirty="0"/>
+              <a:t> fail closed。</a:t>
+            </a:r>
+          </a:p>
+          <a:p>
+            <a:endParaRPr dirty="0"/>
+          </a:p>
+          <a:p>
+            <a:r>
+              <a:rPr dirty="0"/>
               <a:t>[Sources]</a:t>
             </a:r>
           </a:p>
           <a:p>
             <a:r>
-              <a:t>- backend/app/application/room_service.py</a:t>
-            </a:r>
-          </a:p>
-          <a:p>
-            <a:r>
+              <a:rPr dirty="0"/>
+              <a:t>- backend/app/application/</a:t>
+            </a:r>
+            <a:r>
+              <a:rPr dirty="0" err="1"/>
+              <a:t>room_service.py</a:t>
+            </a:r>
+            <a:endParaRPr dirty="0"/>
+          </a:p>
+          <a:p>
+            <a:r>
+              <a:rPr dirty="0"/>
               <a:t>- docs/decisions/0003-adopt-postgresql-room-aggregate-repository.md</a:t>
             </a:r>
           </a:p>
           <a:p>
             <a:r>
-              <a:t>- docs/architecture/llm-integration.md</a:t>
-            </a:r>
-          </a:p>
-          <a:p>
-            <a:r>
+              <a:rPr dirty="0"/>
+              <a:t>- docs/architecture/</a:t>
+            </a:r>
+            <a:r>
+              <a:rPr dirty="0" err="1"/>
+              <a:t>llm-integration.md</a:t>
+            </a:r>
+            <a:endParaRPr dirty="0"/>
+          </a:p>
+          <a:p>
+            <a:r>
+              <a:rPr dirty="0"/>
               <a:t>[/Sources]</a:t>
             </a:r>
           </a:p>
@@ -552,39 +671,162 @@
           <a:lstStyle/>
           <a:p>
             <a:r>
-              <a:t>玩家經 Internet Gateway 進入 public app subnet 的 EC2，資料庫只在 private DB subnets。EC2 透過 Bedrock 產生受約束敘事，CloudWatch 收集 safe application logs，Systems Manager 提供免 SSH 維運。圖上的三條外部依賴分別走上方、下方與管理平面通道，避免與 VPC 或 Subnet 邊界重疊。</a:t>
-            </a:r>
-          </a:p>
-          <a:p>
-            <a:endParaRPr/>
-          </a:p>
-          <a:p>
-            <a:r>
+              <a:rPr dirty="0" err="1"/>
+              <a:t>玩家經</a:t>
+            </a:r>
+            <a:r>
+              <a:rPr dirty="0"/>
+              <a:t> Internet Gateway </a:t>
+            </a:r>
+            <a:r>
+              <a:rPr dirty="0" err="1"/>
+              <a:t>進入</a:t>
+            </a:r>
+            <a:r>
+              <a:rPr dirty="0"/>
+              <a:t> public app subnet </a:t>
+            </a:r>
+            <a:r>
+              <a:rPr dirty="0" err="1"/>
+              <a:t>的</a:t>
+            </a:r>
+            <a:r>
+              <a:rPr dirty="0"/>
+              <a:t> EC2，資料庫只在 private DB subnets。EC2 </a:t>
+            </a:r>
+            <a:r>
+              <a:rPr dirty="0" err="1"/>
+              <a:t>透過</a:t>
+            </a:r>
+            <a:r>
+              <a:rPr dirty="0"/>
+              <a:t> Bedrock </a:t>
+            </a:r>
+            <a:r>
+              <a:rPr dirty="0" err="1"/>
+              <a:t>產生受約束敘事，CloudWatch</a:t>
+            </a:r>
+            <a:r>
+              <a:rPr dirty="0"/>
+              <a:t> </a:t>
+            </a:r>
+            <a:r>
+              <a:rPr dirty="0" err="1"/>
+              <a:t>收集</a:t>
+            </a:r>
+            <a:r>
+              <a:rPr dirty="0"/>
+              <a:t> safe application </a:t>
+            </a:r>
+            <a:r>
+              <a:rPr dirty="0" err="1"/>
+              <a:t>logs，Systems</a:t>
+            </a:r>
+            <a:r>
+              <a:rPr dirty="0"/>
+              <a:t> Manager </a:t>
+            </a:r>
+            <a:r>
+              <a:rPr dirty="0" err="1"/>
+              <a:t>提供免</a:t>
+            </a:r>
+            <a:r>
+              <a:rPr dirty="0"/>
+              <a:t> SSH </a:t>
+            </a:r>
+            <a:r>
+              <a:rPr dirty="0" err="1"/>
+              <a:t>維運。圖上的三條外部依賴分別走上方、下方與管理平面通道，避免與</a:t>
+            </a:r>
+            <a:r>
+              <a:rPr dirty="0"/>
+              <a:t> VPC </a:t>
+            </a:r>
+            <a:r>
+              <a:rPr dirty="0" err="1"/>
+              <a:t>或</a:t>
+            </a:r>
+            <a:r>
+              <a:rPr dirty="0"/>
+              <a:t> Subnet </a:t>
+            </a:r>
+            <a:r>
+              <a:rPr dirty="0" err="1"/>
+              <a:t>邊界重疊</a:t>
+            </a:r>
+            <a:r>
+              <a:rPr dirty="0"/>
+              <a:t>。</a:t>
+            </a:r>
+          </a:p>
+          <a:p>
+            <a:endParaRPr dirty="0"/>
+          </a:p>
+          <a:p>
+            <a:r>
+              <a:rPr dirty="0"/>
               <a:t>[Sources]</a:t>
             </a:r>
           </a:p>
           <a:p>
             <a:r>
-              <a:t>- infra/cloudformation/tier0-network.yaml</a:t>
-            </a:r>
-          </a:p>
-          <a:p>
-            <a:r>
-              <a:t>- infra/cloudformation/tier0-rds.yaml</a:t>
-            </a:r>
-          </a:p>
-          <a:p>
-            <a:r>
-              <a:t>- infra/cloudformation/tier1-observability.yaml</a:t>
-            </a:r>
-          </a:p>
-          <a:p>
-            <a:r>
-              <a:t>- infra/cloudformation/tier1-operations.yaml</a:t>
-            </a:r>
-          </a:p>
-          <a:p>
-            <a:r>
+              <a:rPr dirty="0"/>
+              <a:t>- infra/</a:t>
+            </a:r>
+            <a:r>
+              <a:rPr dirty="0" err="1"/>
+              <a:t>cloudformation</a:t>
+            </a:r>
+            <a:r>
+              <a:rPr dirty="0"/>
+              <a:t>/tier0-network.yaml</a:t>
+            </a:r>
+          </a:p>
+          <a:p>
+            <a:r>
+              <a:rPr dirty="0"/>
+              <a:t>- infra/</a:t>
+            </a:r>
+            <a:r>
+              <a:rPr dirty="0" err="1"/>
+              <a:t>cloudformation</a:t>
+            </a:r>
+            <a:r>
+              <a:rPr dirty="0"/>
+              <a:t>/tier0-rds.yaml</a:t>
+            </a:r>
+          </a:p>
+          <a:p>
+            <a:r>
+              <a:rPr dirty="0"/>
+              <a:t>- infra/</a:t>
+            </a:r>
+            <a:r>
+              <a:rPr dirty="0" err="1"/>
+              <a:t>cloudformation</a:t>
+            </a:r>
+            <a:r>
+              <a:rPr dirty="0"/>
+              <a:t>/tier1-observability.yaml</a:t>
+            </a:r>
+          </a:p>
+          <a:p>
+            <a:r>
+              <a:rPr dirty="0"/>
+              <a:t>- infra/</a:t>
+            </a:r>
+            <a:r>
+              <a:rPr dirty="0" err="1"/>
+              <a:t>cloudformation</a:t>
+            </a:r>
+            <a:r>
+              <a:rPr dirty="0"/>
+              <a:t>/tier1-operations.yaml</a:t>
+            </a:r>
+          </a:p>
+          <a:p>
+            <a:r>
+              <a:rPr dirty="0"/>
               <a:t>[/Sources]</a:t>
             </a:r>
           </a:p>
@@ -897,24 +1139,53 @@
           <a:lstStyle/>
           <a:p>
             <a:r>
-              <a:t>第三章展示安全、成本、SSM 與 CloudWatch 的實機證據，也清楚區分已完成與尚未完成。</a:t>
-            </a:r>
-          </a:p>
-          <a:p>
-            <a:endParaRPr/>
-          </a:p>
-          <a:p>
-            <a:r>
+              <a:rPr dirty="0" err="1"/>
+              <a:t>第三章展示安全、成本、SSM</a:t>
+            </a:r>
+            <a:r>
+              <a:rPr dirty="0"/>
+              <a:t> </a:t>
+            </a:r>
+            <a:r>
+              <a:rPr dirty="0" err="1"/>
+              <a:t>與</a:t>
+            </a:r>
+            <a:r>
+              <a:rPr dirty="0"/>
+              <a:t> CloudWatch </a:t>
+            </a:r>
+            <a:r>
+              <a:rPr dirty="0" err="1"/>
+              <a:t>的實機證據，也清楚區分已完成與尚未完成</a:t>
+            </a:r>
+            <a:r>
+              <a:rPr dirty="0"/>
+              <a:t>。</a:t>
+            </a:r>
+          </a:p>
+          <a:p>
+            <a:endParaRPr dirty="0"/>
+          </a:p>
+          <a:p>
+            <a:r>
+              <a:rPr dirty="0"/>
               <a:t>[Sources]</a:t>
             </a:r>
           </a:p>
           <a:p>
             <a:r>
-              <a:t>- docs/evidence/2026-08-24-tier1-runtime-observability/validation.md</a:t>
-            </a:r>
-          </a:p>
-          <a:p>
-            <a:r>
+              <a:rPr dirty="0"/>
+              <a:t>- docs/evidence/2026-08-24-tier1-runtime-observability/</a:t>
+            </a:r>
+            <a:r>
+              <a:rPr dirty="0" err="1"/>
+              <a:t>validation.md</a:t>
+            </a:r>
+            <a:endParaRPr dirty="0"/>
+          </a:p>
+          <a:p>
+            <a:r>
+              <a:rPr dirty="0"/>
               <a:t>[/Sources]</a:t>
             </a:r>
           </a:p>
@@ -992,34 +1263,129 @@
           <a:lstStyle/>
           <a:p>
             <a:r>
-              <a:t>網路、權限與成本都在部署前被設計。管理面以 SSM 取代 SSH；private RDS 只接受 App SG；AppRole 只取得指定 Bedrock、CloudWatch 與 runtime secret。成本用 US$1 Budget、最小規格、七天 log retention 與明確不建立清單控制。</a:t>
-            </a:r>
-          </a:p>
-          <a:p>
-            <a:endParaRPr/>
-          </a:p>
-          <a:p>
-            <a:r>
+              <a:rPr dirty="0" err="1"/>
+              <a:t>網路、權限與成本都在部署前被設計。管理面以</a:t>
+            </a:r>
+            <a:r>
+              <a:rPr dirty="0"/>
+              <a:t> SSM </a:t>
+            </a:r>
+            <a:r>
+              <a:rPr dirty="0" err="1"/>
+              <a:t>取代</a:t>
+            </a:r>
+            <a:r>
+              <a:rPr dirty="0"/>
+              <a:t> </a:t>
+            </a:r>
+            <a:r>
+              <a:rPr dirty="0" err="1"/>
+              <a:t>SSH；private</a:t>
+            </a:r>
+            <a:r>
+              <a:rPr dirty="0"/>
+              <a:t> RDS </a:t>
+            </a:r>
+            <a:r>
+              <a:rPr dirty="0" err="1"/>
+              <a:t>只接受</a:t>
+            </a:r>
+            <a:r>
+              <a:rPr dirty="0"/>
+              <a:t> App </a:t>
+            </a:r>
+            <a:r>
+              <a:rPr dirty="0" err="1"/>
+              <a:t>SG；AppRole</a:t>
+            </a:r>
+            <a:r>
+              <a:rPr dirty="0"/>
+              <a:t> </a:t>
+            </a:r>
+            <a:r>
+              <a:rPr dirty="0" err="1"/>
+              <a:t>只取得指定</a:t>
+            </a:r>
+            <a:r>
+              <a:rPr dirty="0"/>
+              <a:t> </a:t>
+            </a:r>
+            <a:r>
+              <a:rPr dirty="0" err="1"/>
+              <a:t>Bedrock、CloudWatch</a:t>
+            </a:r>
+            <a:r>
+              <a:rPr dirty="0"/>
+              <a:t> </a:t>
+            </a:r>
+            <a:r>
+              <a:rPr dirty="0" err="1"/>
+              <a:t>與</a:t>
+            </a:r>
+            <a:r>
+              <a:rPr dirty="0"/>
+              <a:t> runtime </a:t>
+            </a:r>
+            <a:r>
+              <a:rPr dirty="0" err="1"/>
+              <a:t>secret。成本用</a:t>
+            </a:r>
+            <a:r>
+              <a:rPr dirty="0"/>
+              <a:t> US$1 </a:t>
+            </a:r>
+            <a:r>
+              <a:rPr dirty="0" err="1"/>
+              <a:t>Budget、最小規格、七天</a:t>
+            </a:r>
+            <a:r>
+              <a:rPr dirty="0"/>
+              <a:t> log retention </a:t>
+            </a:r>
+            <a:r>
+              <a:rPr dirty="0" err="1"/>
+              <a:t>與明確不建立清單控制</a:t>
+            </a:r>
+            <a:r>
+              <a:rPr dirty="0"/>
+              <a:t>。</a:t>
+            </a:r>
+          </a:p>
+          <a:p>
+            <a:endParaRPr dirty="0"/>
+          </a:p>
+          <a:p>
+            <a:r>
+              <a:rPr dirty="0"/>
               <a:t>[Sources]</a:t>
             </a:r>
           </a:p>
           <a:p>
             <a:r>
+              <a:rPr dirty="0"/>
               <a:t>- docs/architecture/tier0-aws-change-envelope.md</a:t>
             </a:r>
           </a:p>
           <a:p>
             <a:r>
-              <a:t>- docs/handoffs/CURRENT.md</a:t>
-            </a:r>
-          </a:p>
-          <a:p>
-            <a:r>
+              <a:rPr dirty="0"/>
+              <a:t>- docs/handoffs/</a:t>
+            </a:r>
+            <a:r>
+              <a:rPr dirty="0" err="1"/>
+              <a:t>CURRENT.md</a:t>
+            </a:r>
+            <a:endParaRPr dirty="0"/>
+          </a:p>
+          <a:p>
+            <a:r>
+              <a:rPr dirty="0"/>
               <a:t>- AWS Architecture Icons 2026 Q3</a:t>
             </a:r>
           </a:p>
           <a:p>
             <a:r>
+              <a:rPr dirty="0"/>
               <a:t>[/Sources]</a:t>
             </a:r>
           </a:p>
@@ -1097,39 +1463,191 @@
           <a:lstStyle/>
           <a:p>
             <a:r>
-              <a:t>FastAPI 只把 allowlist 欄位寫入安全 JSONL，CloudWatch Agent 收集固定檔案並送到七天 retention 的 Log Group。Metric filter 只辨識 500 到 599，Alarm 門檻是一分鐘至少一次。SSM Health Document 已驗證 service、live 與 ready；正向 delivery 已完成，5xx trigger 和 recovery 尚未宣稱完成。</a:t>
-            </a:r>
-          </a:p>
-          <a:p>
-            <a:endParaRPr/>
-          </a:p>
-          <a:p>
-            <a:r>
+              <a:rPr dirty="0" err="1"/>
+              <a:t>FastAPI</a:t>
+            </a:r>
+            <a:r>
+              <a:rPr dirty="0"/>
+              <a:t> </a:t>
+            </a:r>
+            <a:r>
+              <a:rPr dirty="0" err="1"/>
+              <a:t>只把</a:t>
+            </a:r>
+            <a:r>
+              <a:rPr dirty="0"/>
+              <a:t> allowlist </a:t>
+            </a:r>
+            <a:r>
+              <a:rPr dirty="0" err="1"/>
+              <a:t>欄位寫入安全</a:t>
+            </a:r>
+            <a:r>
+              <a:rPr dirty="0"/>
+              <a:t> </a:t>
+            </a:r>
+            <a:r>
+              <a:rPr dirty="0" err="1"/>
+              <a:t>JSONL，CloudWatch</a:t>
+            </a:r>
+            <a:r>
+              <a:rPr dirty="0"/>
+              <a:t> Agent </a:t>
+            </a:r>
+            <a:r>
+              <a:rPr dirty="0" err="1"/>
+              <a:t>收集固定檔案並送到七天</a:t>
+            </a:r>
+            <a:r>
+              <a:rPr dirty="0"/>
+              <a:t> retention </a:t>
+            </a:r>
+            <a:r>
+              <a:rPr dirty="0" err="1"/>
+              <a:t>的</a:t>
+            </a:r>
+            <a:r>
+              <a:rPr dirty="0"/>
+              <a:t> Log </a:t>
+            </a:r>
+            <a:r>
+              <a:rPr dirty="0" err="1"/>
+              <a:t>Group。Metric</a:t>
+            </a:r>
+            <a:r>
+              <a:rPr dirty="0"/>
+              <a:t> filter </a:t>
+            </a:r>
+            <a:r>
+              <a:rPr dirty="0" err="1"/>
+              <a:t>只辨識</a:t>
+            </a:r>
+            <a:r>
+              <a:rPr dirty="0"/>
+              <a:t> 500 </a:t>
+            </a:r>
+            <a:r>
+              <a:rPr dirty="0" err="1"/>
+              <a:t>到</a:t>
+            </a:r>
+            <a:r>
+              <a:rPr dirty="0"/>
+              <a:t> 599，Alarm </a:t>
+            </a:r>
+            <a:r>
+              <a:rPr dirty="0" err="1"/>
+              <a:t>門檻是一分鐘至少一次。SSM</a:t>
+            </a:r>
+            <a:r>
+              <a:rPr dirty="0"/>
+              <a:t> Health Document </a:t>
+            </a:r>
+            <a:r>
+              <a:rPr dirty="0" err="1"/>
+              <a:t>已驗證</a:t>
+            </a:r>
+            <a:r>
+              <a:rPr dirty="0"/>
+              <a:t> </a:t>
+            </a:r>
+            <a:r>
+              <a:rPr dirty="0" err="1"/>
+              <a:t>service、live</a:t>
+            </a:r>
+            <a:r>
+              <a:rPr dirty="0"/>
+              <a:t> </a:t>
+            </a:r>
+            <a:r>
+              <a:rPr dirty="0" err="1"/>
+              <a:t>與</a:t>
+            </a:r>
+            <a:r>
+              <a:rPr dirty="0"/>
+              <a:t> </a:t>
+            </a:r>
+            <a:r>
+              <a:rPr dirty="0" err="1"/>
+              <a:t>ready；正向</a:t>
+            </a:r>
+            <a:r>
+              <a:rPr dirty="0"/>
+              <a:t> delivery 已完成，5xx trigger </a:t>
+            </a:r>
+            <a:r>
+              <a:rPr dirty="0" err="1"/>
+              <a:t>和</a:t>
+            </a:r>
+            <a:r>
+              <a:rPr dirty="0"/>
+              <a:t> recovery </a:t>
+            </a:r>
+            <a:r>
+              <a:rPr dirty="0" err="1"/>
+              <a:t>尚未宣稱完成</a:t>
+            </a:r>
+            <a:r>
+              <a:rPr dirty="0"/>
+              <a:t>。</a:t>
+            </a:r>
+          </a:p>
+          <a:p>
+            <a:endParaRPr dirty="0"/>
+          </a:p>
+          <a:p>
+            <a:r>
+              <a:rPr dirty="0"/>
               <a:t>[Sources]</a:t>
             </a:r>
           </a:p>
           <a:p>
             <a:r>
-              <a:t>- infra/cloudformation/tier1-observability.yaml</a:t>
-            </a:r>
-          </a:p>
-          <a:p>
-            <a:r>
-              <a:t>- infra/cloudformation/tier1-ssm-health-check.yaml</a:t>
-            </a:r>
-          </a:p>
-          <a:p>
-            <a:r>
-              <a:t>- docs/evidence/2026-08-24-tier1-runtime-observability/validation.md</a:t>
-            </a:r>
-          </a:p>
-          <a:p>
-            <a:r>
+              <a:rPr dirty="0"/>
+              <a:t>- infra/</a:t>
+            </a:r>
+            <a:r>
+              <a:rPr dirty="0" err="1"/>
+              <a:t>cloudformation</a:t>
+            </a:r>
+            <a:r>
+              <a:rPr dirty="0"/>
+              <a:t>/tier1-observability.yaml</a:t>
+            </a:r>
+          </a:p>
+          <a:p>
+            <a:r>
+              <a:rPr dirty="0"/>
+              <a:t>- infra/</a:t>
+            </a:r>
+            <a:r>
+              <a:rPr dirty="0" err="1"/>
+              <a:t>cloudformation</a:t>
+            </a:r>
+            <a:r>
+              <a:rPr dirty="0"/>
+              <a:t>/tier1-ssm-health-check.yaml</a:t>
+            </a:r>
+          </a:p>
+          <a:p>
+            <a:r>
+              <a:rPr dirty="0"/>
+              <a:t>- docs/evidence/2026-08-24-tier1-runtime-observability/</a:t>
+            </a:r>
+            <a:r>
+              <a:rPr dirty="0" err="1"/>
+              <a:t>validation.md</a:t>
+            </a:r>
+            <a:endParaRPr dirty="0"/>
+          </a:p>
+          <a:p>
+            <a:r>
+              <a:rPr dirty="0"/>
               <a:t>- AWS Architecture Icons 2026 Q3</a:t>
             </a:r>
           </a:p>
           <a:p>
             <a:r>
+              <a:rPr dirty="0"/>
               <a:t>[/Sources]</a:t>
             </a:r>
           </a:p>
@@ -1207,34 +1725,127 @@
           <a:lstStyle/>
           <a:p>
             <a:r>
-              <a:t>Tier 0 到 Tier 5 是同一產品的累積演進。Tier 0 證明可玩、private data 與 AWS 部署；Tier 1 加入可觀測與免 SSH 維運。後續才做元件隔離、CI/CD、微服務與 Agentic AI，每一層都必須有實際成果和證據。</a:t>
-            </a:r>
-          </a:p>
-          <a:p>
-            <a:endParaRPr/>
-          </a:p>
-          <a:p>
-            <a:r>
+              <a:rPr dirty="0"/>
+              <a:t>Tier 0 </a:t>
+            </a:r>
+            <a:r>
+              <a:rPr dirty="0" err="1"/>
+              <a:t>到</a:t>
+            </a:r>
+            <a:r>
+              <a:rPr dirty="0"/>
+              <a:t> Tier 5 </a:t>
+            </a:r>
+            <a:r>
+              <a:rPr dirty="0" err="1"/>
+              <a:t>是同一產品的累積演進。Tier</a:t>
+            </a:r>
+            <a:r>
+              <a:rPr dirty="0"/>
+              <a:t> 0 </a:t>
+            </a:r>
+            <a:r>
+              <a:rPr dirty="0" err="1"/>
+              <a:t>證明可玩、private</a:t>
+            </a:r>
+            <a:r>
+              <a:rPr dirty="0"/>
+              <a:t> data </a:t>
+            </a:r>
+            <a:r>
+              <a:rPr dirty="0" err="1"/>
+              <a:t>與</a:t>
+            </a:r>
+            <a:r>
+              <a:rPr dirty="0"/>
+              <a:t> AWS </a:t>
+            </a:r>
+            <a:r>
+              <a:rPr dirty="0" err="1"/>
+              <a:t>部署；Tier</a:t>
+            </a:r>
+            <a:r>
+              <a:rPr dirty="0"/>
+              <a:t> 1 </a:t>
+            </a:r>
+            <a:r>
+              <a:rPr dirty="0" err="1"/>
+              <a:t>加入可觀測與免</a:t>
+            </a:r>
+            <a:r>
+              <a:rPr dirty="0"/>
+              <a:t> SSH </a:t>
+            </a:r>
+            <a:r>
+              <a:rPr dirty="0" err="1"/>
+              <a:t>維運。後續才做元件隔離、CI</a:t>
+            </a:r>
+            <a:r>
+              <a:rPr dirty="0"/>
+              <a:t>/</a:t>
+            </a:r>
+            <a:r>
+              <a:rPr dirty="0" err="1"/>
+              <a:t>CD、微服務與</a:t>
+            </a:r>
+            <a:r>
+              <a:rPr dirty="0"/>
+              <a:t> Agentic </a:t>
+            </a:r>
+            <a:r>
+              <a:rPr dirty="0" err="1"/>
+              <a:t>AI，每一層都必須有實際成果和證據</a:t>
+            </a:r>
+            <a:r>
+              <a:rPr dirty="0"/>
+              <a:t>。</a:t>
+            </a:r>
+          </a:p>
+          <a:p>
+            <a:endParaRPr dirty="0"/>
+          </a:p>
+          <a:p>
+            <a:r>
+              <a:rPr dirty="0"/>
               <a:t>[Sources]</a:t>
             </a:r>
           </a:p>
           <a:p>
             <a:r>
-              <a:t>- AGENTS.md</a:t>
-            </a:r>
-          </a:p>
-          <a:p>
-            <a:r>
-              <a:t>- docs/project-plan.md</a:t>
-            </a:r>
-          </a:p>
-          <a:p>
-            <a:r>
-              <a:t>- docs/checkpoints.md</a:t>
-            </a:r>
-          </a:p>
-          <a:p>
-            <a:r>
+              <a:rPr dirty="0"/>
+              <a:t>- </a:t>
+            </a:r>
+            <a:r>
+              <a:rPr dirty="0" err="1"/>
+              <a:t>AGENTS.md</a:t>
+            </a:r>
+            <a:endParaRPr dirty="0"/>
+          </a:p>
+          <a:p>
+            <a:r>
+              <a:rPr dirty="0"/>
+              <a:t>- docs/project-</a:t>
+            </a:r>
+            <a:r>
+              <a:rPr dirty="0" err="1"/>
+              <a:t>plan.md</a:t>
+            </a:r>
+            <a:endParaRPr dirty="0"/>
+          </a:p>
+          <a:p>
+            <a:r>
+              <a:rPr dirty="0"/>
+              <a:t>- docs/</a:t>
+            </a:r>
+            <a:r>
+              <a:rPr dirty="0" err="1"/>
+              <a:t>checkpoints.md</a:t>
+            </a:r>
+            <a:endParaRPr dirty="0"/>
+          </a:p>
+          <a:p>
+            <a:r>
+              <a:rPr dirty="0"/>
               <a:t>[/Sources]</a:t>
             </a:r>
           </a:p>
@@ -1312,29 +1923,80 @@
           <a:lstStyle/>
           <a:p>
             <a:r>
-              <a:t>共演計劃展示的是完整的產品工程能力：把使用者需求轉成系統邊界，把風險轉成安全與 rollback，把部署轉成可重現證據。下一步會完成 5xx alarm、recovery 與 AIOps incident，但每次擴張仍以價值、成本與驗證為前提。</a:t>
-            </a:r>
-          </a:p>
-          <a:p>
-            <a:endParaRPr/>
-          </a:p>
-          <a:p>
-            <a:r>
+              <a:rPr dirty="0" err="1"/>
+              <a:t>共演計劃展示的是完整的產品工程能力：把使用者需求轉成系統邊界，把風險轉成安全與</a:t>
+            </a:r>
+            <a:r>
+              <a:rPr dirty="0"/>
+              <a:t> </a:t>
+            </a:r>
+            <a:r>
+              <a:rPr dirty="0" err="1"/>
+              <a:t>rollback，把部署轉成可重現證據。下一步會完成</a:t>
+            </a:r>
+            <a:r>
+              <a:rPr dirty="0"/>
+              <a:t> 5xx </a:t>
+            </a:r>
+            <a:r>
+              <a:rPr dirty="0" err="1"/>
+              <a:t>alarm、recovery</a:t>
+            </a:r>
+            <a:r>
+              <a:rPr dirty="0"/>
+              <a:t> </a:t>
+            </a:r>
+            <a:r>
+              <a:rPr dirty="0" err="1"/>
+              <a:t>與</a:t>
+            </a:r>
+            <a:r>
+              <a:rPr dirty="0"/>
+              <a:t> AIOps </a:t>
+            </a:r>
+            <a:r>
+              <a:rPr dirty="0" err="1"/>
+              <a:t>incident，但每次擴張仍以價值、成本與驗證為前提</a:t>
+            </a:r>
+            <a:r>
+              <a:rPr dirty="0"/>
+              <a:t>。</a:t>
+            </a:r>
+          </a:p>
+          <a:p>
+            <a:endParaRPr dirty="0"/>
+          </a:p>
+          <a:p>
+            <a:r>
+              <a:rPr dirty="0"/>
               <a:t>[Sources]</a:t>
             </a:r>
           </a:p>
           <a:p>
             <a:r>
-              <a:t>- docs/handoffs/CURRENT.md</a:t>
-            </a:r>
-          </a:p>
-          <a:p>
-            <a:r>
-              <a:t>- docs/project-plan.md</a:t>
-            </a:r>
-          </a:p>
-          <a:p>
-            <a:r>
+              <a:rPr dirty="0"/>
+              <a:t>- docs/handoffs/</a:t>
+            </a:r>
+            <a:r>
+              <a:rPr dirty="0" err="1"/>
+              <a:t>CURRENT.md</a:t>
+            </a:r>
+            <a:endParaRPr dirty="0"/>
+          </a:p>
+          <a:p>
+            <a:r>
+              <a:rPr dirty="0"/>
+              <a:t>- docs/project-</a:t>
+            </a:r>
+            <a:r>
+              <a:rPr dirty="0" err="1"/>
+              <a:t>plan.md</a:t>
+            </a:r>
+            <a:endParaRPr dirty="0"/>
+          </a:p>
+          <a:p>
+            <a:r>
+              <a:rPr dirty="0"/>
               <a:t>[/Sources]</a:t>
             </a:r>
           </a:p>
@@ -1412,24 +2074,37 @@
           <a:lstStyle/>
           <a:p>
             <a:r>
-              <a:t>第一章先談產品問題與價值。服務選型只有在問題被說清楚後才有意義。</a:t>
-            </a:r>
-          </a:p>
-          <a:p>
-            <a:endParaRPr/>
-          </a:p>
-          <a:p>
-            <a:r>
+              <a:rPr dirty="0" err="1"/>
+              <a:t>第一章先談產品問題與價值。服務選型只有在問題被說清楚後才有意義</a:t>
+            </a:r>
+            <a:r>
+              <a:rPr dirty="0"/>
+              <a:t>。</a:t>
+            </a:r>
+          </a:p>
+          <a:p>
+            <a:endParaRPr dirty="0"/>
+          </a:p>
+          <a:p>
+            <a:r>
+              <a:rPr dirty="0"/>
               <a:t>[Sources]</a:t>
             </a:r>
           </a:p>
           <a:p>
             <a:r>
-              <a:t>- docs/product/source-of-truth.md</a:t>
-            </a:r>
-          </a:p>
-          <a:p>
-            <a:r>
+              <a:rPr dirty="0"/>
+              <a:t>- docs/product/source-of-</a:t>
+            </a:r>
+            <a:r>
+              <a:rPr dirty="0" err="1"/>
+              <a:t>truth.md</a:t>
+            </a:r>
+            <a:endParaRPr dirty="0"/>
+          </a:p>
+          <a:p>
+            <a:r>
+              <a:rPr dirty="0"/>
               <a:t>[/Sources]</a:t>
             </a:r>
           </a:p>
@@ -1507,29 +2182,80 @@
           <a:lstStyle/>
           <a:p>
             <a:r>
-              <a:t>多人共創真正困難的是同步與共識。共演計劃讓 server 維持 canonical state 與 deterministic rules，AI 只在既定結果上生成敘事，因此同一核心能從娛樂延伸到培訓模擬、共創工作坊與互動內容。</a:t>
-            </a:r>
-          </a:p>
-          <a:p>
-            <a:endParaRPr/>
-          </a:p>
-          <a:p>
-            <a:r>
+              <a:rPr dirty="0" err="1"/>
+              <a:t>多人共創真正困難的是同步與共識。共演計劃讓</a:t>
+            </a:r>
+            <a:r>
+              <a:rPr dirty="0"/>
+              <a:t> server </a:t>
+            </a:r>
+            <a:r>
+              <a:rPr dirty="0" err="1"/>
+              <a:t>維持</a:t>
+            </a:r>
+            <a:r>
+              <a:rPr dirty="0"/>
+              <a:t> canonical state </a:t>
+            </a:r>
+            <a:r>
+              <a:rPr dirty="0" err="1"/>
+              <a:t>與</a:t>
+            </a:r>
+            <a:r>
+              <a:rPr dirty="0"/>
+              <a:t> deterministic </a:t>
+            </a:r>
+            <a:r>
+              <a:rPr dirty="0" err="1"/>
+              <a:t>rules，AI</a:t>
+            </a:r>
+            <a:r>
+              <a:rPr dirty="0"/>
+              <a:t> </a:t>
+            </a:r>
+            <a:r>
+              <a:rPr dirty="0" err="1"/>
+              <a:t>只在既定結果上生成敘事，因此同一核心能從娛樂延伸到培訓模擬、共創工作坊與互動內容</a:t>
+            </a:r>
+            <a:r>
+              <a:rPr dirty="0"/>
+              <a:t>。</a:t>
+            </a:r>
+          </a:p>
+          <a:p>
+            <a:endParaRPr dirty="0"/>
+          </a:p>
+          <a:p>
+            <a:r>
+              <a:rPr dirty="0"/>
               <a:t>[Sources]</a:t>
             </a:r>
           </a:p>
           <a:p>
             <a:r>
-              <a:t>- docs/product/source-of-truth.md</a:t>
-            </a:r>
-          </a:p>
-          <a:p>
-            <a:r>
-              <a:t>- docs/project-plan.md</a:t>
-            </a:r>
-          </a:p>
-          <a:p>
-            <a:r>
+              <a:rPr dirty="0"/>
+              <a:t>- docs/product/source-of-</a:t>
+            </a:r>
+            <a:r>
+              <a:rPr dirty="0" err="1"/>
+              <a:t>truth.md</a:t>
+            </a:r>
+            <a:endParaRPr dirty="0"/>
+          </a:p>
+          <a:p>
+            <a:r>
+              <a:rPr dirty="0"/>
+              <a:t>- docs/project-</a:t>
+            </a:r>
+            <a:r>
+              <a:rPr dirty="0" err="1"/>
+              <a:t>plan.md</a:t>
+            </a:r>
+            <a:endParaRPr dirty="0"/>
+          </a:p>
+          <a:p>
+            <a:r>
+              <a:rPr dirty="0"/>
               <a:t>[/Sources]</a:t>
             </a:r>
           </a:p>
@@ -1607,29 +2333,68 @@
           <a:lstStyle/>
           <a:p>
             <a:r>
-              <a:t>RPG 是第一個可驗證場景，但核心不是奇幻故事，而是多人輸入、共同狀態、規則結算與 AI 受約束輸出。換成會議時，回合可對應議程與發言，AI 產生摘要和行動項；換成培訓時，規則可變成評估標準。這兩項是商業延伸概念，尚未實作。</a:t>
-            </a:r>
-          </a:p>
-          <a:p>
-            <a:endParaRPr/>
-          </a:p>
-          <a:p>
-            <a:r>
+              <a:rPr dirty="0"/>
+              <a:t>RPG </a:t>
+            </a:r>
+            <a:r>
+              <a:rPr dirty="0" err="1"/>
+              <a:t>是第一個可驗證場景，但核心不是奇幻故事，而是多人輸入、共同狀態、規則結算與</a:t>
+            </a:r>
+            <a:r>
+              <a:rPr dirty="0"/>
+              <a:t> AI </a:t>
+            </a:r>
+            <a:r>
+              <a:rPr dirty="0" err="1"/>
+              <a:t>受約束輸出。換成會議時，回合可對應議程與發言，AI</a:t>
+            </a:r>
+            <a:r>
+              <a:rPr dirty="0"/>
+              <a:t> </a:t>
+            </a:r>
+            <a:r>
+              <a:rPr dirty="0" err="1"/>
+              <a:t>產生摘要和行動項；換成培訓時，規則可變成評估標準。這兩項是商業延伸概念，尚未實作</a:t>
+            </a:r>
+            <a:r>
+              <a:rPr dirty="0"/>
+              <a:t>。</a:t>
+            </a:r>
+          </a:p>
+          <a:p>
+            <a:endParaRPr dirty="0"/>
+          </a:p>
+          <a:p>
+            <a:r>
+              <a:rPr dirty="0"/>
               <a:t>[Sources]</a:t>
             </a:r>
           </a:p>
           <a:p>
             <a:r>
-              <a:t>- docs/product/source-of-truth.md</a:t>
-            </a:r>
-          </a:p>
-          <a:p>
-            <a:r>
-              <a:t>- 產品延伸推論，未宣稱已實作</a:t>
-            </a:r>
-          </a:p>
-          <a:p>
-            <a:r>
+              <a:rPr dirty="0"/>
+              <a:t>- docs/product/source-of-</a:t>
+            </a:r>
+            <a:r>
+              <a:rPr dirty="0" err="1"/>
+              <a:t>truth.md</a:t>
+            </a:r>
+            <a:endParaRPr dirty="0"/>
+          </a:p>
+          <a:p>
+            <a:r>
+              <a:rPr dirty="0"/>
+              <a:t>- </a:t>
+            </a:r>
+            <a:r>
+              <a:rPr dirty="0" err="1"/>
+              <a:t>產品延伸推論，未宣稱已實作</a:t>
+            </a:r>
+            <a:endParaRPr dirty="0"/>
+          </a:p>
+          <a:p>
+            <a:r>
+              <a:rPr dirty="0"/>
               <a:t>[/Sources]</a:t>
             </a:r>
           </a:p>
@@ -1707,29 +2472,64 @@
           <a:lstStyle/>
           <a:p>
             <a:r>
-              <a:t>玩家只需要加入房間、提交行動、擲骰並閱讀共同故事。前端不接觸 AWS credential；後端結算規則和狀態，最後才把結果交給 Bedrock 轉成敘事。這個責任分離讓產品體驗簡單，也讓雲端元件能獨立替換。</a:t>
-            </a:r>
-          </a:p>
-          <a:p>
-            <a:endParaRPr/>
-          </a:p>
-          <a:p>
-            <a:r>
+              <a:rPr dirty="0" err="1"/>
+              <a:t>玩家只需要加入房間、提交行動、擲骰並閱讀共同故事。前端不接觸</a:t>
+            </a:r>
+            <a:r>
+              <a:rPr dirty="0"/>
+              <a:t> AWS </a:t>
+            </a:r>
+            <a:r>
+              <a:rPr dirty="0" err="1"/>
+              <a:t>credential；後端結算規則和狀態，最後才把結果交給</a:t>
+            </a:r>
+            <a:r>
+              <a:rPr dirty="0"/>
+              <a:t> Bedrock </a:t>
+            </a:r>
+            <a:r>
+              <a:rPr dirty="0" err="1"/>
+              <a:t>轉成敘事。這個責任分離讓產品體驗簡單，也讓雲端元件能獨立替換</a:t>
+            </a:r>
+            <a:r>
+              <a:rPr dirty="0"/>
+              <a:t>。</a:t>
+            </a:r>
+          </a:p>
+          <a:p>
+            <a:endParaRPr dirty="0"/>
+          </a:p>
+          <a:p>
+            <a:r>
+              <a:rPr dirty="0"/>
               <a:t>[Sources]</a:t>
             </a:r>
           </a:p>
           <a:p>
             <a:r>
-              <a:t>- docs/architecture/frontend-clean-architecture.md</a:t>
-            </a:r>
-          </a:p>
-          <a:p>
-            <a:r>
-              <a:t>- docs/architecture/llm-integration.md</a:t>
-            </a:r>
-          </a:p>
-          <a:p>
-            <a:r>
+              <a:rPr dirty="0"/>
+              <a:t>- docs/architecture/frontend-clean-</a:t>
+            </a:r>
+            <a:r>
+              <a:rPr dirty="0" err="1"/>
+              <a:t>architecture.md</a:t>
+            </a:r>
+            <a:endParaRPr dirty="0"/>
+          </a:p>
+          <a:p>
+            <a:r>
+              <a:rPr dirty="0"/>
+              <a:t>- docs/architecture/</a:t>
+            </a:r>
+            <a:r>
+              <a:rPr dirty="0" err="1"/>
+              <a:t>llm-integration.md</a:t>
+            </a:r>
+            <a:endParaRPr dirty="0"/>
+          </a:p>
+          <a:p>
+            <a:r>
+              <a:rPr dirty="0"/>
               <a:t>[/Sources]</a:t>
             </a:r>
           </a:p>
@@ -1807,29 +2607,64 @@
           <a:lstStyle/>
           <a:p>
             <a:r>
-              <a:t>這是公開 AWS 環境的實際遊玩畫面。四位玩家使用不同裝置完成世界生成、角色建立、四回合、AI 敘事、結局與刪房。這證明的是產品閉環，而不是只有單機畫面或後端測試。</a:t>
-            </a:r>
-          </a:p>
-          <a:p>
-            <a:endParaRPr/>
-          </a:p>
-          <a:p>
-            <a:r>
+              <a:rPr dirty="0" err="1"/>
+              <a:t>這是公開</a:t>
+            </a:r>
+            <a:r>
+              <a:rPr dirty="0"/>
+              <a:t> AWS </a:t>
+            </a:r>
+            <a:r>
+              <a:rPr dirty="0" err="1"/>
+              <a:t>環境的實際遊玩畫面。四位玩家使用不同裝置完成世界生成、角色建立、四回合、AI</a:t>
+            </a:r>
+            <a:r>
+              <a:rPr dirty="0"/>
+              <a:t> </a:t>
+            </a:r>
+            <a:r>
+              <a:rPr dirty="0" err="1"/>
+              <a:t>敘事、結局與刪房。這證明的是產品閉環，而不是只有單機畫面或後端測試</a:t>
+            </a:r>
+            <a:r>
+              <a:rPr dirty="0"/>
+              <a:t>。</a:t>
+            </a:r>
+          </a:p>
+          <a:p>
+            <a:endParaRPr dirty="0"/>
+          </a:p>
+          <a:p>
+            <a:r>
+              <a:rPr dirty="0"/>
               <a:t>[Sources]</a:t>
             </a:r>
           </a:p>
           <a:p>
             <a:r>
-              <a:t>- docs/evidence/2026-08-20-tier0-four-player-trial/validation.md</a:t>
-            </a:r>
-          </a:p>
-          <a:p>
-            <a:r>
-              <a:t>- 內部實際遊玩截圖</a:t>
-            </a:r>
-          </a:p>
-          <a:p>
-            <a:r>
+              <a:rPr dirty="0"/>
+              <a:t>- docs/evidence/2026-08-20-tier0-four-player-trial/</a:t>
+            </a:r>
+            <a:r>
+              <a:rPr dirty="0" err="1"/>
+              <a:t>validation.md</a:t>
+            </a:r>
+            <a:endParaRPr dirty="0"/>
+          </a:p>
+          <a:p>
+            <a:r>
+              <a:rPr dirty="0"/>
+              <a:t>- </a:t>
+            </a:r>
+            <a:r>
+              <a:rPr dirty="0" err="1"/>
+              <a:t>內部實際遊玩截圖</a:t>
+            </a:r>
+            <a:endParaRPr dirty="0"/>
+          </a:p>
+          <a:p>
+            <a:r>
+              <a:rPr dirty="0"/>
               <a:t>[/Sources]</a:t>
             </a:r>
           </a:p>
@@ -1907,24 +2742,40 @@
           <a:lstStyle/>
           <a:p>
             <a:r>
-              <a:t>第二章從問題回推服務。接下來依序說明服務選型、Nova Lite、模型抽換與實際部署架構。</a:t>
-            </a:r>
-          </a:p>
-          <a:p>
-            <a:endParaRPr/>
-          </a:p>
-          <a:p>
-            <a:r>
+              <a:rPr dirty="0" err="1"/>
+              <a:t>第二章從問題回推服務。接下來依序說明服務選型、Nova</a:t>
+            </a:r>
+            <a:r>
+              <a:rPr dirty="0"/>
+              <a:t> </a:t>
+            </a:r>
+            <a:r>
+              <a:rPr dirty="0" err="1"/>
+              <a:t>Lite、模型抽換與實際部署架構</a:t>
+            </a:r>
+            <a:r>
+              <a:rPr dirty="0"/>
+              <a:t>。</a:t>
+            </a:r>
+          </a:p>
+          <a:p>
+            <a:endParaRPr dirty="0"/>
+          </a:p>
+          <a:p>
+            <a:r>
+              <a:rPr dirty="0"/>
               <a:t>[Sources]</a:t>
             </a:r>
           </a:p>
           <a:p>
             <a:r>
+              <a:rPr dirty="0"/>
               <a:t>- docs/architecture/tier0-aws-deployment-plan.md</a:t>
             </a:r>
           </a:p>
           <a:p>
             <a:r>
+              <a:rPr dirty="0"/>
               <a:t>[/Sources]</a:t>
             </a:r>
           </a:p>
@@ -2002,34 +2853,136 @@
           <a:lstStyle/>
           <a:p>
             <a:r>
-              <a:t>EC2 解決的是單一 process MVP 的可控部署；RDS 解決多人狀態與跨重啟 persistence；Bedrock 提供受治理的模型入口；SSM 讓維運不開 SSH；CloudWatch 把 log 轉成可查詢、可告警的操作證據。未使用的 NAT Gateway、ALB、ECS 等服務不是缺漏，而是目前沒有足夠價值支撐成本與複雜度。</a:t>
-            </a:r>
-          </a:p>
-          <a:p>
-            <a:endParaRPr/>
-          </a:p>
-          <a:p>
-            <a:r>
+              <a:rPr dirty="0"/>
+              <a:t>EC2 </a:t>
+            </a:r>
+            <a:r>
+              <a:rPr dirty="0" err="1"/>
+              <a:t>解決的是單一</a:t>
+            </a:r>
+            <a:r>
+              <a:rPr dirty="0"/>
+              <a:t> process MVP </a:t>
+            </a:r>
+            <a:r>
+              <a:rPr dirty="0" err="1"/>
+              <a:t>的可控部署；RDS</a:t>
+            </a:r>
+            <a:r>
+              <a:rPr dirty="0"/>
+              <a:t> </a:t>
+            </a:r>
+            <a:r>
+              <a:rPr dirty="0" err="1"/>
+              <a:t>解決多人狀態與跨重啟</a:t>
+            </a:r>
+            <a:r>
+              <a:rPr dirty="0"/>
+              <a:t> </a:t>
+            </a:r>
+            <a:r>
+              <a:rPr dirty="0" err="1"/>
+              <a:t>persistence；Bedrock</a:t>
+            </a:r>
+            <a:r>
+              <a:rPr dirty="0"/>
+              <a:t> </a:t>
+            </a:r>
+            <a:r>
+              <a:rPr dirty="0" err="1"/>
+              <a:t>提供受治理的模型入口；SSM</a:t>
+            </a:r>
+            <a:r>
+              <a:rPr dirty="0"/>
+              <a:t> </a:t>
+            </a:r>
+            <a:r>
+              <a:rPr dirty="0" err="1"/>
+              <a:t>讓維運不開</a:t>
+            </a:r>
+            <a:r>
+              <a:rPr dirty="0"/>
+              <a:t> SSH；CloudWatch </a:t>
+            </a:r>
+            <a:r>
+              <a:rPr dirty="0" err="1"/>
+              <a:t>把</a:t>
+            </a:r>
+            <a:r>
+              <a:rPr dirty="0"/>
+              <a:t> log </a:t>
+            </a:r>
+            <a:r>
+              <a:rPr dirty="0" err="1"/>
+              <a:t>轉成可查詢、可告警的操作證據。未使用的</a:t>
+            </a:r>
+            <a:r>
+              <a:rPr dirty="0"/>
+              <a:t> NAT </a:t>
+            </a:r>
+            <a:r>
+              <a:rPr dirty="0" err="1"/>
+              <a:t>Gateway、ALB、ECS</a:t>
+            </a:r>
+            <a:r>
+              <a:rPr dirty="0"/>
+              <a:t> </a:t>
+            </a:r>
+            <a:r>
+              <a:rPr dirty="0" err="1"/>
+              <a:t>等服務不是缺漏，而是目前沒有足夠價值支撐成本與複雜度</a:t>
+            </a:r>
+            <a:r>
+              <a:rPr dirty="0"/>
+              <a:t>。</a:t>
+            </a:r>
+          </a:p>
+          <a:p>
+            <a:endParaRPr dirty="0"/>
+          </a:p>
+          <a:p>
+            <a:r>
+              <a:rPr dirty="0"/>
               <a:t>[Sources]</a:t>
             </a:r>
           </a:p>
           <a:p>
             <a:r>
+              <a:rPr dirty="0"/>
               <a:t>- docs/architecture/tier0-aws-deployment-plan.md</a:t>
             </a:r>
           </a:p>
           <a:p>
             <a:r>
-              <a:t>- infra/cloudformation/tier0-network.yaml</a:t>
-            </a:r>
-          </a:p>
-          <a:p>
-            <a:r>
-              <a:t>- infra/cloudformation/tier0-rds.yaml</a:t>
-            </a:r>
-          </a:p>
-          <a:p>
-            <a:r>
+              <a:rPr dirty="0"/>
+              <a:t>- infra/</a:t>
+            </a:r>
+            <a:r>
+              <a:rPr dirty="0" err="1"/>
+              <a:t>cloudformation</a:t>
+            </a:r>
+            <a:r>
+              <a:rPr dirty="0"/>
+              <a:t>/tier0-network.yaml</a:t>
+            </a:r>
+          </a:p>
+          <a:p>
+            <a:r>
+              <a:rPr dirty="0"/>
+              <a:t>- infra/</a:t>
+            </a:r>
+            <a:r>
+              <a:rPr dirty="0" err="1"/>
+              <a:t>cloudformation</a:t>
+            </a:r>
+            <a:r>
+              <a:rPr dirty="0"/>
+              <a:t>/tier0-rds.yaml</a:t>
+            </a:r>
+          </a:p>
+          <a:p>
+            <a:r>
+              <a:rPr dirty="0"/>
               <a:t>[/Sources]</a:t>
             </a:r>
           </a:p>
@@ -2107,49 +3060,192 @@
           <a:lstStyle/>
           <a:p>
             <a:r>
-              <a:t>Nova Lite 是目前已部署模型。AWS 將它定位為低成本、快速的 multimodal model；本專案只使用文字輸入，互動回合看重的是等待時間和成本平衡，而不是最大推理能力。程式以 Storyteller port 隔離應用層，Bedrock adapter 使用 Converse，model ID 由環境設定，因此在同介面模型間切換主要是設定與驗證工作，不需改寫遊戲規則。但『可抽換』不等於免測試，仍要重跑 schema、品質、延遲、成本、Region、IAM 與 Guardrail gate。</a:t>
-            </a:r>
-          </a:p>
-          <a:p>
-            <a:endParaRPr/>
-          </a:p>
-          <a:p>
-            <a:r>
+              <a:rPr dirty="0"/>
+              <a:t>Nova Lite </a:t>
+            </a:r>
+            <a:r>
+              <a:rPr dirty="0" err="1"/>
+              <a:t>是目前已部署模型。AWS</a:t>
+            </a:r>
+            <a:r>
+              <a:rPr dirty="0"/>
+              <a:t> </a:t>
+            </a:r>
+            <a:r>
+              <a:rPr dirty="0" err="1"/>
+              <a:t>將它定位為低成本、快速的</a:t>
+            </a:r>
+            <a:r>
+              <a:rPr dirty="0"/>
+              <a:t> multimodal </a:t>
+            </a:r>
+            <a:r>
+              <a:rPr dirty="0" err="1"/>
+              <a:t>model；本專案只使用文字輸入，互動回合看重的是等待時間和成本平衡，而不是最大推理能力。程式以</a:t>
+            </a:r>
+            <a:r>
+              <a:rPr dirty="0"/>
+              <a:t> Storyteller port </a:t>
+            </a:r>
+            <a:r>
+              <a:rPr dirty="0" err="1"/>
+              <a:t>隔離應用層，Bedrock</a:t>
+            </a:r>
+            <a:r>
+              <a:rPr dirty="0"/>
+              <a:t> adapter </a:t>
+            </a:r>
+            <a:r>
+              <a:rPr dirty="0" err="1"/>
+              <a:t>使用</a:t>
+            </a:r>
+            <a:r>
+              <a:rPr dirty="0"/>
+              <a:t> </a:t>
+            </a:r>
+            <a:r>
+              <a:rPr dirty="0" err="1"/>
+              <a:t>Converse，model</a:t>
+            </a:r>
+            <a:r>
+              <a:rPr dirty="0"/>
+              <a:t> ID </a:t>
+            </a:r>
+            <a:r>
+              <a:rPr dirty="0" err="1"/>
+              <a:t>由環境設定，因此在同介面模型間切換主要是設定與驗證工作，不需改寫遊戲規則。但『可抽換』不等於免測試，仍要重跑</a:t>
+            </a:r>
+            <a:r>
+              <a:rPr dirty="0"/>
+              <a:t> </a:t>
+            </a:r>
+            <a:r>
+              <a:rPr dirty="0" err="1"/>
+              <a:t>schema、品質、延遲、成本、Region、IAM</a:t>
+            </a:r>
+            <a:r>
+              <a:rPr dirty="0"/>
+              <a:t> </a:t>
+            </a:r>
+            <a:r>
+              <a:rPr dirty="0" err="1"/>
+              <a:t>與</a:t>
+            </a:r>
+            <a:r>
+              <a:rPr dirty="0"/>
+              <a:t> Guardrail gate。</a:t>
+            </a:r>
+          </a:p>
+          <a:p>
+            <a:endParaRPr dirty="0"/>
+          </a:p>
+          <a:p>
+            <a:r>
+              <a:rPr dirty="0"/>
               <a:t>[Sources]</a:t>
             </a:r>
           </a:p>
           <a:p>
             <a:r>
-              <a:t>- https://docs.aws.amazon.com/bedrock/latest/userguide/model-card-amazon-nova-lite.html</a:t>
-            </a:r>
-          </a:p>
-          <a:p>
-            <a:r>
-              <a:t>- https://docs.aws.amazon.com/bedrock/latest/userguide/apis.html</a:t>
-            </a:r>
-          </a:p>
-          <a:p>
-            <a:r>
-              <a:t>- backend/app/application/ports.py</a:t>
-            </a:r>
-          </a:p>
-          <a:p>
-            <a:r>
-              <a:t>- backend/app/adapters/bedrock_storyteller.py</a:t>
-            </a:r>
-          </a:p>
-          <a:p>
-            <a:r>
-              <a:t>- backend/app/main.py</a:t>
-            </a:r>
-          </a:p>
-          <a:p>
-            <a:r>
-              <a:t>- ops/release/enable_public_https.sh</a:t>
-            </a:r>
-          </a:p>
-          <a:p>
-            <a:r>
+              <a:rPr dirty="0"/>
+              <a:t>- https://</a:t>
+            </a:r>
+            <a:r>
+              <a:rPr dirty="0" err="1"/>
+              <a:t>docs.aws.amazon.com</a:t>
+            </a:r>
+            <a:r>
+              <a:rPr dirty="0"/>
+              <a:t>/bedrock/latest/</a:t>
+            </a:r>
+            <a:r>
+              <a:rPr dirty="0" err="1"/>
+              <a:t>userguide</a:t>
+            </a:r>
+            <a:r>
+              <a:rPr dirty="0"/>
+              <a:t>/model-card-amazon-nova-</a:t>
+            </a:r>
+            <a:r>
+              <a:rPr dirty="0" err="1"/>
+              <a:t>lite.html</a:t>
+            </a:r>
+            <a:endParaRPr dirty="0"/>
+          </a:p>
+          <a:p>
+            <a:r>
+              <a:rPr dirty="0"/>
+              <a:t>- https://</a:t>
+            </a:r>
+            <a:r>
+              <a:rPr dirty="0" err="1"/>
+              <a:t>docs.aws.amazon.com</a:t>
+            </a:r>
+            <a:r>
+              <a:rPr dirty="0"/>
+              <a:t>/bedrock/latest/</a:t>
+            </a:r>
+            <a:r>
+              <a:rPr dirty="0" err="1"/>
+              <a:t>userguide</a:t>
+            </a:r>
+            <a:r>
+              <a:rPr dirty="0"/>
+              <a:t>/</a:t>
+            </a:r>
+            <a:r>
+              <a:rPr dirty="0" err="1"/>
+              <a:t>apis.html</a:t>
+            </a:r>
+            <a:endParaRPr dirty="0"/>
+          </a:p>
+          <a:p>
+            <a:r>
+              <a:rPr dirty="0"/>
+              <a:t>- backend/app/application/</a:t>
+            </a:r>
+            <a:r>
+              <a:rPr dirty="0" err="1"/>
+              <a:t>ports.py</a:t>
+            </a:r>
+            <a:endParaRPr dirty="0"/>
+          </a:p>
+          <a:p>
+            <a:r>
+              <a:rPr dirty="0"/>
+              <a:t>- backend/app/adapters/</a:t>
+            </a:r>
+            <a:r>
+              <a:rPr dirty="0" err="1"/>
+              <a:t>bedrock_storyteller.py</a:t>
+            </a:r>
+            <a:endParaRPr dirty="0"/>
+          </a:p>
+          <a:p>
+            <a:r>
+              <a:rPr dirty="0"/>
+              <a:t>- backend/app/</a:t>
+            </a:r>
+            <a:r>
+              <a:rPr dirty="0" err="1"/>
+              <a:t>main.py</a:t>
+            </a:r>
+            <a:endParaRPr dirty="0"/>
+          </a:p>
+          <a:p>
+            <a:r>
+              <a:rPr dirty="0"/>
+              <a:t>- ops/release/</a:t>
+            </a:r>
+            <a:r>
+              <a:rPr dirty="0" err="1"/>
+              <a:t>enable_public_https.sh</a:t>
+            </a:r>
+            <a:endParaRPr dirty="0"/>
+          </a:p>
+          <a:p>
+            <a:r>
+              <a:rPr dirty="0"/>
               <a:t>[/Sources]</a:t>
             </a:r>
           </a:p>

</xml_diff>